<commit_message>
Docs: tick completed hackathon checklist; regenerated 3-minute deck and Canva report screenshot
Co-Authored-By: Claude Opus 5.5 <noreply@anthropic.com>
</commit_message>
<xml_diff>
--- a/docs/pitch/out/BlockID-Startup-Passport-3min.pptx
+++ b/docs/pitch/out/BlockID-Startup-Passport-3min.pptx
@@ -772,7 +772,7 @@
           <a:p>
             <a:r>
               <a:rPr lang="en-US" dirty="0"/>
-              <a:t>[1:15–1:40] The AI only suggests scores. A fixed, public formula turns seven weighted dimensions into a grade and a valuation range, and any claim without a fetched source is dropped. For Airwallex it found eight real competitors and graded it C.</a:t>
+              <a:t>[1:15–1:40] The AI only suggests scores. A fixed, public formula turns seven weighted dimensions into a grade and a valuation range, and any claim without a fetched source is dropped. For Canva it found nine real competitors, a cited ARR of A$6 billion and an implied multiple from its last round.</a:t>
             </a:r>
             <a:endParaRPr lang="en-US" dirty="0"/>
           </a:p>
@@ -1036,7 +1036,7 @@
           <a:p>
             <a:r>
               <a:rPr lang="en-US" dirty="0"/>
-              <a:t>[2:25–3:00] This is live today: twelve real companies, thirty-six token contracts on three chains, A$69.8 billion of indicative valuation on-chain, every hash verified. Our customers are founders, accelerators and licensed intermediaries who issue and administer startup equity. Scan the code and try it at eth.blockid.au — we're looking for pilot startups and licensed partners. Thank you.</a:t>
+              <a:t>[2:25–3:00] This is live today: twelve real companies, thirty-six token contracts on three chains, A$87 billion of valuation on-chain, every hash verified. Our full demo run took Canva from its website to a share register on three chains, a new round, a dividend and a shareholder transfer in eleven minutes. Our customers are founders, accelerators and licensed intermediaries who issue and administer startup equity. Scan the code and try it at eth.blockid.au — we're looking for pilot startups and licensed partners. Thank you.</a:t>
             </a:r>
             <a:endParaRPr lang="en-US" dirty="0"/>
           </a:p>
@@ -5016,11 +5016,11 @@
         <p:spPr>
           <a:xfrm>
             <a:off x="457200" y="1600200"/>
-            <a:ext cx="7726680" cy="3919664"/>
+            <a:ext cx="7726680" cy="4174172"/>
           </a:xfrm>
           <a:prstGeom prst="roundRect">
             <a:avLst>
-              <a:gd name="adj" fmla="val 1866"/>
+              <a:gd name="adj" fmla="val 1752"/>
             </a:avLst>
           </a:prstGeom>
           <a:solidFill>
@@ -5058,7 +5058,7 @@
         <p:spPr>
           <a:xfrm>
             <a:off x="502920" y="1645920"/>
-            <a:ext cx="7635240" cy="3828224"/>
+            <a:ext cx="7635240" cy="4082732"/>
           </a:xfrm>
           <a:prstGeom prst="rect">
             <a:avLst/>
@@ -5381,7 +5381,7 @@
                 <a:ea typeface="Calibri" pitchFamily="34" charset="-122"/>
                 <a:cs typeface="Calibri" pitchFamily="34" charset="-120"/>
               </a:rPr>
-              <a:t>Airwallex → 8 competitors found (Wise, Revolut, OFX…) → SVI 54.5 · grade C</a:t>
+              <a:t>Canva: 9 competitors · ARR A$6B cited · 10.5x implied · A$64B mid</a:t>
             </a:r>
             <a:endParaRPr lang="en-US" sz="1300" dirty="0"/>
           </a:p>
@@ -5545,11 +5545,11 @@
         <p:spPr>
           <a:xfrm>
             <a:off x="457200" y="1600200"/>
-            <a:ext cx="5623560" cy="3933190"/>
+            <a:ext cx="5623560" cy="2415699"/>
           </a:xfrm>
           <a:prstGeom prst="roundRect">
             <a:avLst>
-              <a:gd name="adj" fmla="val 1860"/>
+              <a:gd name="adj" fmla="val 3028"/>
             </a:avLst>
           </a:prstGeom>
           <a:solidFill>
@@ -5587,7 +5587,7 @@
         <p:spPr>
           <a:xfrm>
             <a:off x="502920" y="1645920"/>
-            <a:ext cx="5532120" cy="3841750"/>
+            <a:ext cx="5532120" cy="2324259"/>
           </a:xfrm>
           <a:prstGeom prst="rect">
             <a:avLst/>
@@ -6909,7 +6909,7 @@
                 <a:ea typeface="Arial" pitchFamily="34" charset="-122"/>
                 <a:cs typeface="Arial" pitchFamily="34" charset="-120"/>
               </a:rPr>
-              <a:t>A$69.8B</a:t>
+              <a:t>A$87B</a:t>
             </a:r>
             <a:endParaRPr lang="en-US" sz="3000" dirty="0"/>
           </a:p>
@@ -6948,7 +6948,7 @@
                 <a:ea typeface="Calibri" pitchFamily="34" charset="-122"/>
                 <a:cs typeface="Calibri" pitchFamily="34" charset="-120"/>
               </a:rPr>
-              <a:t>indicative valuation on-chain</a:t>
+              <a:t>valuation on-chain</a:t>
             </a:r>
             <a:endParaRPr lang="en-US" sz="1200" dirty="0"/>
           </a:p>
@@ -7014,7 +7014,7 @@
                 <a:ea typeface="Arial" pitchFamily="34" charset="-122"/>
                 <a:cs typeface="Arial" pitchFamily="34" charset="-120"/>
               </a:rPr>
-              <a:t>100%</a:t>
+              <a:t>12/12</a:t>
             </a:r>
             <a:endParaRPr lang="en-US" sz="3000" dirty="0"/>
           </a:p>

</xml_diff>